<commit_message>
Final changes that were not pushed
</commit_message>
<xml_diff>
--- a/presentation.pptx
+++ b/presentation.pptx
@@ -6234,7 +6234,43 @@
                 </a:solidFill>
                 <a:latin typeface="Helvetica Neue"/>
               </a:rPr>
-              <a:t>6. Standalone inference system + web interface for non-technical use</a:t>
+              <a:t>6. Standalone inference system</a:t>
+            </a:r>
+            <a:r>
+              <a:rPr lang="en-US" sz="1700" b="0" dirty="0">
+                <a:solidFill>
+                  <a:srgbClr val="000000"/>
+                </a:solidFill>
+                <a:latin typeface="Helvetica Neue"/>
+              </a:rPr>
+              <a:t>;</a:t>
+            </a:r>
+            <a:r>
+              <a:rPr sz="1700" b="0" dirty="0">
+                <a:solidFill>
+                  <a:srgbClr val="000000"/>
+                </a:solidFill>
+                <a:latin typeface="Helvetica Neue"/>
+              </a:rPr>
+              <a:t> </a:t>
+            </a:r>
+            <a:r>
+              <a:rPr lang="en-US" sz="1700" b="0" dirty="0">
+                <a:solidFill>
+                  <a:srgbClr val="000000"/>
+                </a:solidFill>
+                <a:latin typeface="Helvetica Neue"/>
+              </a:rPr>
+              <a:t>demo </a:t>
+            </a:r>
+            <a:r>
+              <a:rPr sz="1700" b="0" dirty="0">
+                <a:solidFill>
+                  <a:srgbClr val="000000"/>
+                </a:solidFill>
+                <a:latin typeface="Helvetica Neue"/>
+              </a:rPr>
+              <a:t>web interface for non-technical use</a:t>
             </a:r>
           </a:p>
         </p:txBody>

</xml_diff>